<commit_message>
fix(fraude): alinhar PPTX com metricas multi-seed e adicionar benchmark de latencia no notebook
</commit_message>
<xml_diff>
--- a/O-Fim-da-Fraude-Silenciosa-Protegendo-a-Receita-e-a-Experiencia-do-Cliente.pptx
+++ b/O-Fim-da-Fraude-Silenciosa-Protegendo-a-Receita-e-a-Experiencia-do-Cliente.pptx
@@ -1406,7 +1406,7 @@
                 <a:ea typeface="Epilogue" pitchFamily="34" charset="-122"/>
                 <a:cs typeface="Epilogue" pitchFamily="34" charset="-120"/>
               </a:rPr>
-              <a:t>Instituições financeiras perdem milhões de reais anualmente com fraudes transacionais, enquanto arcam com altos custos operacionais de suporte ao cliente ao tentar bloquear transações de forma manual.</a:t>
+              <a:t>Instituições perdem anualmente com fraudes não detectadas (FN a R$ 1.500/caso) e arcam com altos custos operacionais ao bloquear clientes legítimos (FP a R$ 100/caso).</a:t>
             </a:r>
             <a:endParaRPr lang="en-US" sz="1050" dirty="0"/>
           </a:p>
@@ -1522,7 +1522,7 @@
                 <a:ea typeface="Epilogue" pitchFamily="34" charset="-122"/>
                 <a:cs typeface="Epilogue" pitchFamily="34" charset="-120"/>
               </a:rPr>
-              <a:t>Regras estáticas e modelos lineares tradicionais não acompanham a sofisticação dos fraudadores, gerando alto índice de Falsos Positivos e atrito com clientes legítimos.</a:t>
+              <a:t>Regras estáticas manuais (F1 de 0,059) e modelos lineares geram excesso de falsos alarmes (1.400 FPs no teste) e deixam passar fraudes complexas.</a:t>
             </a:r>
             <a:endParaRPr lang="en-US" sz="1050" dirty="0"/>
           </a:p>
@@ -1638,7 +1638,7 @@
                 <a:ea typeface="Epilogue" pitchFamily="34" charset="-122"/>
                 <a:cs typeface="Epilogue" pitchFamily="34" charset="-120"/>
               </a:rPr>
-              <a:t>Redes Neurais (MLP) adaptadas para dados desbalanceados, capazes de identificar padrões não-lineares complexos em milissegundos, reduzindo perdas e eliminando atritos.</a:t>
+              <a:t>Rede Neural MLP com Oversampling e limiar ótimo (0.80), identificando padrões não lineares em &lt;30ms, economizando R$ 504k/ano com ROI de +323,5%.</a:t>
             </a:r>
             <a:endParaRPr lang="en-US" sz="1050" dirty="0"/>
           </a:p>
@@ -1931,7 +1931,7 @@
                 <a:ea typeface="Epilogue" pitchFamily="34" charset="-122"/>
                 <a:cs typeface="Epilogue" pitchFamily="34" charset="-120"/>
               </a:rPr>
-              <a:t>Atributos transacionais nativos: valor, horário, frequência em 24h, geolocalização e novos dispositivos.</a:t>
+              <a:t>Atributos transacionais nativos: valor, horário, frequência em 24h, distância do local habitual e novos dispositivos.</a:t>
             </a:r>
             <a:endParaRPr lang="en-US" sz="1200" dirty="0"/>
           </a:p>
@@ -2468,7 +2468,7 @@
                 <a:ea typeface="Fraunces Medium" pitchFamily="34" charset="-122"/>
                 <a:cs typeface="Fraunces Medium" pitchFamily="34" charset="-120"/>
               </a:rPr>
-              <a:t>+23.5%</a:t>
+              <a:t>+30.7%</a:t>
             </a:r>
             <a:endParaRPr lang="en-US" sz="3050" dirty="0"/>
           </a:p>
@@ -2552,7 +2552,7 @@
                 <a:ea typeface="Epilogue" pitchFamily="34" charset="-122"/>
                 <a:cs typeface="Epilogue" pitchFamily="34" charset="-120"/>
               </a:rPr>
-              <a:t>Ganho sobre o baseline, equilibrando precisão e recall na detecção de fraudes.</a:t>
+              <a:t>Ganho médio multi-seed sobre o baseline (0,217 vs 0,166) com 0% de colapso.</a:t>
             </a:r>
             <a:endParaRPr lang="en-US" sz="900" dirty="0"/>
           </a:p>
@@ -2594,7 +2594,7 @@
                 <a:ea typeface="Fraunces Medium" pitchFamily="34" charset="-122"/>
                 <a:cs typeface="Fraunces Medium" pitchFamily="34" charset="-120"/>
               </a:rPr>
-              <a:t>+43%</a:t>
+              <a:t>+43.8%</a:t>
             </a:r>
             <a:endParaRPr lang="en-US" sz="3050" dirty="0"/>
           </a:p>
@@ -2678,7 +2678,7 @@
                 <a:ea typeface="Epilogue" pitchFamily="34" charset="-122"/>
                 <a:cs typeface="Epilogue" pitchFamily="34" charset="-120"/>
               </a:rPr>
-              <a:t>Redução drástica de Falsos Positivos, eliminando atrito com clientes legítimos.</a:t>
+              <a:t>Ganho médio multi-seed (0,138 vs 0,096), reduzindo drasticamente falsos alarmes.</a:t>
             </a:r>
             <a:endParaRPr lang="en-US" sz="900" dirty="0"/>
           </a:p>
@@ -2720,7 +2720,7 @@
                 <a:ea typeface="Fraunces Medium" pitchFamily="34" charset="-122"/>
                 <a:cs typeface="Fraunces Medium" pitchFamily="34" charset="-120"/>
               </a:rPr>
-              <a:t>&gt;51%</a:t>
+              <a:t>51.4%</a:t>
             </a:r>
             <a:endParaRPr lang="en-US" sz="3050" dirty="0"/>
           </a:p>
@@ -2804,7 +2804,7 @@
                 <a:ea typeface="Epilogue" pitchFamily="34" charset="-122"/>
                 <a:cs typeface="Epilogue" pitchFamily="34" charset="-120"/>
               </a:rPr>
-              <a:t>Captura constante de fraudes reais, otimizando a matriz de custos operacionais.</a:t>
+              <a:t>Recall balanceado (51,4%), com limiar ótimo (0.80) minimizando o custo total.</a:t>
             </a:r>
             <a:endParaRPr lang="en-US" sz="900" dirty="0"/>
           </a:p>
@@ -2930,7 +2930,7 @@
                 <a:ea typeface="Epilogue" pitchFamily="34" charset="-122"/>
                 <a:cs typeface="Epilogue" pitchFamily="34" charset="-120"/>
               </a:rPr>
-              <a:t>Inferência em tempo real sem fricção para o cliente final.</a:t>
+              <a:t>Inferência em tempo real (benchmark de ~0.1ms em CPU; SLA de produção &lt;30ms).</a:t>
             </a:r>
             <a:endParaRPr lang="en-US" sz="900" dirty="0"/>
           </a:p>
@@ -2972,7 +2972,7 @@
                 <a:ea typeface="Fraunces Medium" pitchFamily="34" charset="-122"/>
                 <a:cs typeface="Fraunces Medium" pitchFamily="34" charset="-120"/>
               </a:rPr>
-              <a:t>Validação Segura</a:t>
+              <a:t>Retorno Financeiro e ROI</a:t>
             </a:r>
             <a:endParaRPr lang="en-US" sz="1150" dirty="0"/>
           </a:p>
@@ -3016,7 +3016,7 @@
                 <a:ea typeface="Epilogue" pitchFamily="34" charset="-122"/>
                 <a:cs typeface="Epilogue" pitchFamily="34" charset="-120"/>
               </a:rPr>
-              <a:t>Validação empírica </a:t>
+              <a:t>ROI de </a:t>
             </a:r>
             <a:pPr algn="l" indent="0" marL="0">
               <a:lnSpc>
@@ -3033,7 +3033,7 @@
                 <a:ea typeface="Epilogue Bold" pitchFamily="34" charset="-122"/>
                 <a:cs typeface="Epilogue Bold" pitchFamily="34" charset="-120"/>
               </a:rPr>
-              <a:t>multi-seed</a:t>
+              <a:t>+323,5%</a:t>
             </a:r>
             <a:pPr algn="l" indent="0" marL="0">
               <a:lnSpc>
@@ -3050,7 +3050,7 @@
                 <a:ea typeface="Epilogue" pitchFamily="34" charset="-122"/>
                 <a:cs typeface="Epilogue" pitchFamily="34" charset="-120"/>
               </a:rPr>
-              <a:t> (seeds 42, 7 e 123) comprovando estabilidade estatística do modelo, seguida de fase piloto em </a:t>
+              <a:t> no 1º ano (Capex R$ 65k, Opex R$ 54k), Payback 2,8 meses e economia de R$ 504k/ano sob </a:t>
             </a:r>
             <a:pPr algn="l" indent="0" marL="0">
               <a:lnSpc>
@@ -3084,7 +3084,7 @@
                 <a:ea typeface="Epilogue" pitchFamily="34" charset="-122"/>
                 <a:cs typeface="Epilogue" pitchFamily="34" charset="-120"/>
               </a:rPr>
-              <a:t> em produção antes do rollout oficial.</a:t>
+              <a:t> com validação multi-seed (0% colapso).</a:t>
             </a:r>
             <a:endParaRPr lang="en-US" sz="900" dirty="0"/>
           </a:p>
@@ -3344,7 +3344,7 @@
                 <a:ea typeface="Epilogue" pitchFamily="34" charset="-122"/>
                 <a:cs typeface="Epilogue" pitchFamily="34" charset="-120"/>
               </a:rPr>
-              <a:t>Pilot Shadow Mode e ajuste de limiar</a:t>
+              <a:t>Pilot Shadow Mode e calibração de limiar 0.80</a:t>
             </a:r>
             <a:endParaRPr lang="en-US" sz="900" dirty="0"/>
           </a:p>
@@ -3474,7 +3474,7 @@
                 <a:ea typeface="Epilogue" pitchFamily="34" charset="-122"/>
                 <a:cs typeface="Epilogue" pitchFamily="34" charset="-120"/>
               </a:rPr>
-              <a:t>Rollout oficial</a:t>
+              <a:t>Rollout gradual, Drift via PSI e retreino mensal</a:t>
             </a:r>
             <a:endParaRPr lang="en-US" sz="900" dirty="0"/>
           </a:p>

</xml_diff>